<commit_message>
Rename slides mode to LinkPresent
- page: slides.html -> linkpresent.html, served at /linkpresent
- on-screen brand, page title, probe label and saved view key
- README section, server banner, parser docstring
- sample deck title slide now says "sample deck for LinkPresent"

Co-Authored-By: Claude Opus 5.5 <noreply@anthropic.com>
Claude-Session: https://claude.ai/code/session_01Gd6teWy1NFk9JnDLkzWXjw
</commit_message>
<xml_diff>
--- a/decks/velora-q3-2026-qbr.pptx
+++ b/decks/velora-q3-2026-qbr.pptx
@@ -124,12 +124,12 @@
   <p:extLst>
     <p:ext uri="{521415D9-36F7-43E2-AB2F-B90AF26B5E84}">
       <p14:sectionLst xmlns:p14="http://schemas.microsoft.com/office/powerpoint/2010/main">
-        <p14:section name="Introduction" id="{f5732027-e777-7dc7-8a1c-37a3e80bec14}">
+        <p14:section name="Introduction" id="{27565529-b155-950f-8a7d-1b68d4538120}">
           <p14:sldIdLst>
             <p14:sldId id="257"/>
           </p14:sldIdLst>
         </p14:section>
-        <p14:section name="Financial performance" id="{424df404-ab3a-de04-7416-a71ea596009f}">
+        <p14:section name="Financial performance" id="{d89b62d5-dad4-77f5-ddf6-b1509cac76ff}">
           <p14:sldIdLst>
             <p14:sldId id="258"/>
             <p14:sldId id="259"/>
@@ -139,7 +139,7 @@
             <p14:sldId id="263"/>
           </p14:sldIdLst>
         </p14:section>
-        <p14:section name="Projects and delivery" id="{0c1252a1-c89f-501a-de7b-a162b16a9a17}">
+        <p14:section name="Projects and delivery" id="{f5f0c1c0-1851-c5c6-1776-44318ad7e616}">
           <p14:sldIdLst>
             <p14:sldId id="264"/>
             <p14:sldId id="265"/>
@@ -148,7 +148,7 @@
             <p14:sldId id="268"/>
           </p14:sldIdLst>
         </p14:section>
-        <p14:section name="Company updates" id="{552fc668-c35e-6243-ce4d-dce8d75c9ad2}">
+        <p14:section name="Company updates" id="{aaf6e36e-9047-7459-c3da-f36670730d05}">
           <p14:sldIdLst>
             <p14:sldId id="269"/>
             <p14:sldId id="270"/>
@@ -156,7 +156,7 @@
             <p14:sldId id="272"/>
           </p14:sldIdLst>
         </p14:section>
-        <p14:section name="Outlook" id="{e58e0d01-cfde-16d2-c36a-df83eaf83e27}">
+        <p14:section name="Outlook" id="{3c9678d9-b2e1-6289-fdb4-4e7b771a82bb}">
           <p14:sldIdLst>
             <p14:sldId id="273"/>
           </p14:sldIdLst>
@@ -5260,7 +5260,7 @@
                   <a:schemeClr val="accent3"/>
                 </a:solidFill>
               </a:rPr>
-              <a:t>Fictional company and figures — sample deck for HOLO</a:t>
+              <a:t>Fictional company and figures — sample deck for LinkPresent</a:t>
             </a:r>
             <a:endParaRPr lang="en-US" sz="1200" dirty="0"/>
           </a:p>

</xml_diff>